<commit_message>
Veterinary report and deck: confirm BioSystems BA200 and Mindray BC-700, no NABL for vet tests
Names the Mindray BC-700 series and its veterinary implications (no
species mode, no animal ESR, validate BC-780 reticulocytes), confirms the
BioSystems BA200, and records the decision to run veterinary tests
outside the NABL scope, with no NABL symbol on veterinary reports.

Co-Authored-By: Claude Opus 5.5 <noreply@anthropic.com>
Claude-Session: https://claude.ai/code/session_01CSkzjv2pUKWCAnTTv8qteA
</commit_message>
<xml_diff>
--- a/dhruv-athlete-healthcheck/veterinary/Dhruv_Veterinary_Reference_Lab_Pitch_Deck.pptx
+++ b/dhruv-athlete-healthcheck/veterinary/Dhruv_Veterinary_Reference_Lab_Pitch_Deck.pptx
@@ -118,30 +118,30 @@
   <p:extLst>
     <p:ext uri="{521415D9-36F7-43E2-AB2F-B90AF26B5E84}">
       <p14:sectionLst xmlns:p14="http://schemas.microsoft.com/office/powerpoint/2010/main">
-        <p14:section name="Opening" id="{6e1641cb-77f3-0307-6ee5-6c7bef3d9782}">
+        <p14:section name="Opening" id="{106ecf9a-aeea-2cc6-98da-8a415dba57ee}">
           <p14:sldIdLst>
             <p14:sldId id="256"/>
           </p14:sldIdLst>
         </p14:section>
-        <p14:section name="Why" id="{858c84b8-87b1-8c1f-edd8-db910befa917}">
+        <p14:section name="Why" id="{7c516029-f4d7-70ba-868c-a43e86558ad7}">
           <p14:sldIdLst>
             <p14:sldId id="257"/>
             <p14:sldId id="258"/>
           </p14:sldIdLst>
         </p14:section>
-        <p14:section name="Offer" id="{da95671a-1000-9ad8-906e-733c0a2083c2}">
+        <p14:section name="Offer" id="{a20effa7-3a5c-7c4a-e73b-449b31d188d4}">
           <p14:sldIdLst>
             <p14:sldId id="259"/>
             <p14:sldId id="260"/>
           </p14:sldIdLst>
         </p14:section>
-        <p14:section name="Trust" id="{7f922866-2899-b981-9961-96ba20678d12}">
+        <p14:section name="Trust" id="{25e41df0-8e63-ab40-1416-e6119d73df8c}">
           <p14:sldIdLst>
             <p14:sldId id="261"/>
             <p14:sldId id="262"/>
           </p14:sldIdLst>
         </p14:section>
-        <p14:section name="Terms" id="{29c5145e-2a41-b0a6-0933-2fb32b57ed27}">
+        <p14:section name="Terms" id="{25c057f4-fa73-ba43-88bc-cfd0bf4a3290}">
           <p14:sldIdLst>
             <p14:sldId id="263"/>
             <p14:sldId id="264"/>
@@ -1518,7 +1518,7 @@
           <a:p>
             <a:r>
               <a:rPr lang="en-US" dirty="0"/>
-              <a:t>NABL accreditation covers Dhruv's human testing. Veterinary accreditation (ISO/IEC 17025) is being applied for; do not describe veterinary tests as NABL-accredited until that scope is granted.</a:t>
+              <a:t>Veterinary tests are outside Dhruv's NABL scope. Do not describe them as NABL-accredited and do not show the NABL symbol on veterinary material or reports.</a:t>
             </a:r>
             <a:endParaRPr lang="en-US" dirty="0"/>
           </a:p>
@@ -2607,7 +2607,7 @@
                   <a:srgbClr val="C9D8F5"/>
                 </a:solidFill>
               </a:rPr>
-              <a:t>   |   NABL-accredited human lab since 2011</a:t>
+              <a:t>   |   Same analysers and quality system as our human lab</a:t>
             </a:r>
             <a:endParaRPr lang="en-US" sz="1150" dirty="0"/>
           </a:p>
@@ -6516,7 +6516,7 @@
                   <a:srgbClr val="C9D8F5"/>
                 </a:solidFill>
               </a:rPr>
-              <a:t>The same analysers, controls and NABL-accredited quality system Dhruv has run for human patients since 2011.</a:t>
+              <a:t>The same analysers, controls and quality system Dhruv has run for human patients for more than 30 years.</a:t>
             </a:r>
             <a:endParaRPr lang="en-US" sz="1200" dirty="0"/>
           </a:p>

</xml_diff>

<commit_message>
Veterinary deck and report: redraw dog, cat and cow; add human PCR and BioFire section
- Replace blob animals with spline-outline silhouettes (sitting Labrador, sitting cat,
  Holstein cow with broad muzzle, dewlap, udder and tail switch)
- Report section 3.6: scrub typhus PCR, human tick-borne PCR and BioFire panels are not
  offered for animals, with reasons and sources; veterinary tick PCR kits on the open
  real-time PCR instruments instead
- Correct the four-city dog survey figure on the PCR slide (49.7% by PCR vs 2.3% by smear)

Co-Authored-By: Claude Opus 5.5 <noreply@anthropic.com>
Claude-Session: https://claude.ai/code/session_01CSkzjv2pUKWCAnTTv8qteA
</commit_message>
<xml_diff>
--- a/dhruv-athlete-healthcheck/veterinary/Dhruv_Veterinary_Reference_Lab_Pitch_Deck.pptx
+++ b/dhruv-athlete-healthcheck/veterinary/Dhruv_Veterinary_Reference_Lab_Pitch_Deck.pptx
@@ -118,30 +118,30 @@
   <p:extLst>
     <p:ext uri="{521415D9-36F7-43E2-AB2F-B90AF26B5E84}">
       <p14:sectionLst xmlns:p14="http://schemas.microsoft.com/office/powerpoint/2010/main">
-        <p14:section name="Opening" id="{106ecf9a-aeea-2cc6-98da-8a415dba57ee}">
+        <p14:section name="Opening" id="{e598b36f-d852-0285-78b4-a928e5ae7eff}">
           <p14:sldIdLst>
             <p14:sldId id="256"/>
           </p14:sldIdLst>
         </p14:section>
-        <p14:section name="Why" id="{7c516029-f4d7-70ba-868c-a43e86558ad7}">
+        <p14:section name="Why" id="{8005f937-9439-a468-1cb0-f5fee0ea930d}">
           <p14:sldIdLst>
             <p14:sldId id="257"/>
             <p14:sldId id="258"/>
           </p14:sldIdLst>
         </p14:section>
-        <p14:section name="Offer" id="{a20effa7-3a5c-7c4a-e73b-449b31d188d4}">
+        <p14:section name="Offer" id="{5187111d-ec26-3f13-27c4-6f59e420e934}">
           <p14:sldIdLst>
             <p14:sldId id="259"/>
             <p14:sldId id="260"/>
           </p14:sldIdLst>
         </p14:section>
-        <p14:section name="Trust" id="{25e41df0-8e63-ab40-1416-e6119d73df8c}">
+        <p14:section name="Trust" id="{2b89f365-bef2-f509-48d8-8d06820b64c6}">
           <p14:sldIdLst>
             <p14:sldId id="261"/>
             <p14:sldId id="262"/>
           </p14:sldIdLst>
         </p14:section>
-        <p14:section name="Terms" id="{25c057f4-fa73-ba43-88bc-cfd0bf4a3290}">
+        <p14:section name="Terms" id="{75ce0321-aad6-3e97-6470-50a34f2bc246}">
           <p14:sldIdLst>
             <p14:sldId id="263"/>
             <p14:sldId id="264"/>
@@ -4950,7 +4950,7 @@
                   <a:schemeClr val="tx1"/>
                 </a:solidFill>
               </a:rPr>
-              <a:t>Half the dogs in the four-city survey carried at least one tick-borne pathogen, and 39% of those carried more than one</a:t>
+              <a:t>In the four-city survey PCR found infection in 49.7% of dogs; blood smears found 2.3%</a:t>
             </a:r>
             <a:endParaRPr lang="en-US" sz="1250" dirty="0"/>
           </a:p>

</xml_diff>